<commit_message>
Porta l'analisi IAM alla v0.13, l'analisi ANSC alla v3.44 e crea il documento del workflow fino alla v0.3
- IAM v0.13: strutture dati riscritte sulle DDL reali di management (schema in Sorgenti
  Documentali), DDL Oracle v0.2.
- ANSC v3.43/v3.44: allineamento al processo del capitolo 13, tabella unica ANSC_STATO_ATTO
  con testata del modello evento e dati di ripresa.
- WORKFLOW_Interfacce-SIPO-ANSC v0.1-v0.3: interfacce del workflow pagina per pagina,
  diagramma a stati, ipotesi di schermata in stile SIPO e diagrammi a stati delle pagine
  nuove, schermate separate con banner di arrivo e percorso fra le schermate.
- Generatori e figure in Documenti finali/strumenti.

Co-Authored-By: Claude Opus 5.5 <noreply@anthropic.com>
</commit_message>
<xml_diff>
--- a/Documenti finali/strumenti/img/workflow_ansc_sipo.pptx
+++ b/Documenti finali/strumenti/img/workflow_ansc_sipo.pptx
@@ -302,7 +302,7 @@
           <a:p>
             <a:fld id="{5BCAD085-E8A6-8845-BD4E-CB4CCA059FC4}" type="datetimeFigureOut">
               <a:rPr lang="en-US" smtClean="0"/>
-              <a:t>10/15/26</a:t>
+              <a:t>10/21/26</a:t>
             </a:fld>
             <a:endParaRPr lang="en-US"/>
           </a:p>
@@ -470,7 +470,7 @@
           <a:p>
             <a:fld id="{5BCAD085-E8A6-8845-BD4E-CB4CCA059FC4}" type="datetimeFigureOut">
               <a:rPr lang="en-US" smtClean="0"/>
-              <a:t>10/15/26</a:t>
+              <a:t>10/21/26</a:t>
             </a:fld>
             <a:endParaRPr lang="en-US"/>
           </a:p>
@@ -648,7 +648,7 @@
           <a:p>
             <a:fld id="{5BCAD085-E8A6-8845-BD4E-CB4CCA059FC4}" type="datetimeFigureOut">
               <a:rPr lang="en-US" smtClean="0"/>
-              <a:t>10/15/26</a:t>
+              <a:t>10/21/26</a:t>
             </a:fld>
             <a:endParaRPr lang="en-US"/>
           </a:p>
@@ -816,7 +816,7 @@
           <a:p>
             <a:fld id="{5BCAD085-E8A6-8845-BD4E-CB4CCA059FC4}" type="datetimeFigureOut">
               <a:rPr lang="en-US" smtClean="0"/>
-              <a:t>10/15/26</a:t>
+              <a:t>10/21/26</a:t>
             </a:fld>
             <a:endParaRPr lang="en-US"/>
           </a:p>
@@ -1061,7 +1061,7 @@
           <a:p>
             <a:fld id="{5BCAD085-E8A6-8845-BD4E-CB4CCA059FC4}" type="datetimeFigureOut">
               <a:rPr lang="en-US" smtClean="0"/>
-              <a:t>10/15/26</a:t>
+              <a:t>10/21/26</a:t>
             </a:fld>
             <a:endParaRPr lang="en-US"/>
           </a:p>
@@ -1346,7 +1346,7 @@
           <a:p>
             <a:fld id="{5BCAD085-E8A6-8845-BD4E-CB4CCA059FC4}" type="datetimeFigureOut">
               <a:rPr lang="en-US" smtClean="0"/>
-              <a:t>10/15/26</a:t>
+              <a:t>10/21/26</a:t>
             </a:fld>
             <a:endParaRPr lang="en-US"/>
           </a:p>
@@ -1765,7 +1765,7 @@
           <a:p>
             <a:fld id="{5BCAD085-E8A6-8845-BD4E-CB4CCA059FC4}" type="datetimeFigureOut">
               <a:rPr lang="en-US" smtClean="0"/>
-              <a:t>10/15/26</a:t>
+              <a:t>10/21/26</a:t>
             </a:fld>
             <a:endParaRPr lang="en-US"/>
           </a:p>
@@ -1882,7 +1882,7 @@
           <a:p>
             <a:fld id="{5BCAD085-E8A6-8845-BD4E-CB4CCA059FC4}" type="datetimeFigureOut">
               <a:rPr lang="en-US" smtClean="0"/>
-              <a:t>10/15/26</a:t>
+              <a:t>10/21/26</a:t>
             </a:fld>
             <a:endParaRPr lang="en-US"/>
           </a:p>
@@ -1977,7 +1977,7 @@
           <a:p>
             <a:fld id="{5BCAD085-E8A6-8845-BD4E-CB4CCA059FC4}" type="datetimeFigureOut">
               <a:rPr lang="en-US" smtClean="0"/>
-              <a:t>10/15/26</a:t>
+              <a:t>10/21/26</a:t>
             </a:fld>
             <a:endParaRPr lang="en-US"/>
           </a:p>
@@ -2252,7 +2252,7 @@
           <a:p>
             <a:fld id="{5BCAD085-E8A6-8845-BD4E-CB4CCA059FC4}" type="datetimeFigureOut">
               <a:rPr lang="en-US" smtClean="0"/>
-              <a:t>10/15/26</a:t>
+              <a:t>10/21/26</a:t>
             </a:fld>
             <a:endParaRPr lang="en-US"/>
           </a:p>
@@ -2504,7 +2504,7 @@
           <a:p>
             <a:fld id="{5BCAD085-E8A6-8845-BD4E-CB4CCA059FC4}" type="datetimeFigureOut">
               <a:rPr lang="en-US" smtClean="0"/>
-              <a:t>10/15/26</a:t>
+              <a:t>10/21/26</a:t>
             </a:fld>
             <a:endParaRPr lang="en-US"/>
           </a:p>
@@ -2715,7 +2715,7 @@
           <a:p>
             <a:fld id="{5BCAD085-E8A6-8845-BD4E-CB4CCA059FC4}" type="datetimeFigureOut">
               <a:rPr lang="en-US" smtClean="0"/>
-              <a:t>10/15/26</a:t>
+              <a:t>10/21/26</a:t>
             </a:fld>
             <a:endParaRPr lang="en-US"/>
           </a:p>
@@ -3122,85 +3122,13 @@
           <a:p>
             <a:pPr algn="ctr"/>
             <a:r>
-              <a:rPr sz="1500" b="1" i="0" dirty="0">
+              <a:rPr lang="it-IT" sz="1500" b="1" i="0" noProof="0" dirty="0">
                 <a:solidFill>
                   <a:srgbClr val="1F3A5F"/>
                 </a:solidFill>
                 <a:latin typeface="Arial"/>
               </a:rPr>
-              <a:t>Il </a:t>
-            </a:r>
-            <a:r>
-              <a:rPr sz="1500" b="1" i="0">
-                <a:solidFill>
-                  <a:srgbClr val="1F3A5F"/>
-                </a:solidFill>
-                <a:latin typeface="Arial"/>
-              </a:rPr>
-              <a:t>processo</a:t>
-            </a:r>
-            <a:r>
-              <a:rPr sz="1500" b="1" i="0" dirty="0">
-                <a:solidFill>
-                  <a:srgbClr val="1F3A5F"/>
-                </a:solidFill>
-                <a:latin typeface="Arial"/>
-              </a:rPr>
-              <a:t> di </a:t>
-            </a:r>
-            <a:r>
-              <a:rPr sz="1500" b="1" i="0" dirty="0" err="1">
-                <a:solidFill>
-                  <a:srgbClr val="1F3A5F"/>
-                </a:solidFill>
-                <a:latin typeface="Arial"/>
-              </a:rPr>
-              <a:t>gestione</a:t>
-            </a:r>
-            <a:r>
-              <a:rPr sz="1500" b="1" i="0" dirty="0">
-                <a:solidFill>
-                  <a:srgbClr val="1F3A5F"/>
-                </a:solidFill>
-                <a:latin typeface="Arial"/>
-              </a:rPr>
-              <a:t> </a:t>
-            </a:r>
-            <a:r>
-              <a:rPr sz="1500" b="1" i="0" dirty="0" err="1">
-                <a:solidFill>
-                  <a:srgbClr val="1F3A5F"/>
-                </a:solidFill>
-                <a:latin typeface="Arial"/>
-              </a:rPr>
-              <a:t>dei</a:t>
-            </a:r>
-            <a:r>
-              <a:rPr sz="1500" b="1" i="0" dirty="0">
-                <a:solidFill>
-                  <a:srgbClr val="1F3A5F"/>
-                </a:solidFill>
-                <a:latin typeface="Arial"/>
-              </a:rPr>
-              <a:t> </a:t>
-            </a:r>
-            <a:r>
-              <a:rPr sz="1500" b="1" i="0" dirty="0" err="1">
-                <a:solidFill>
-                  <a:srgbClr val="1F3A5F"/>
-                </a:solidFill>
-                <a:latin typeface="Arial"/>
-              </a:rPr>
-              <a:t>dati</a:t>
-            </a:r>
-            <a:r>
-              <a:rPr sz="1500" b="1" i="0" dirty="0">
-                <a:solidFill>
-                  <a:srgbClr val="1F3A5F"/>
-                </a:solidFill>
-                <a:latin typeface="Arial"/>
-              </a:rPr>
-              <a:t> ANSC in SIPO</a:t>
+              <a:t>Il processo di gestione dei dati ANSC in SIPO</a:t>
             </a:r>
           </a:p>
         </p:txBody>
@@ -3229,175 +3157,13 @@
           <a:p>
             <a:pPr algn="ctr"/>
             <a:r>
-              <a:rPr sz="850" b="0" i="1" dirty="0">
+              <a:rPr lang="it-IT" sz="850" b="0" i="1" noProof="0" dirty="0">
                 <a:solidFill>
                   <a:srgbClr val="6B7280"/>
                 </a:solidFill>
                 <a:latin typeface="Arial"/>
               </a:rPr>
-              <a:t>Le </a:t>
-            </a:r>
-            <a:r>
-              <a:rPr sz="850" b="0" i="1" dirty="0" err="1">
-                <a:solidFill>
-                  <a:srgbClr val="6B7280"/>
-                </a:solidFill>
-                <a:latin typeface="Arial"/>
-              </a:rPr>
-              <a:t>pagine</a:t>
-            </a:r>
-            <a:r>
-              <a:rPr sz="850" b="0" i="1" dirty="0">
-                <a:solidFill>
-                  <a:srgbClr val="6B7280"/>
-                </a:solidFill>
-                <a:latin typeface="Arial"/>
-              </a:rPr>
-              <a:t> di SIPO, </a:t>
-            </a:r>
-            <a:r>
-              <a:rPr sz="850" b="0" i="1" dirty="0" err="1">
-                <a:solidFill>
-                  <a:srgbClr val="6B7280"/>
-                </a:solidFill>
-                <a:latin typeface="Arial"/>
-              </a:rPr>
-              <a:t>i</a:t>
-            </a:r>
-            <a:r>
-              <a:rPr sz="850" b="0" i="1" dirty="0">
-                <a:solidFill>
-                  <a:srgbClr val="6B7280"/>
-                </a:solidFill>
-                <a:latin typeface="Arial"/>
-              </a:rPr>
-              <a:t> </a:t>
-            </a:r>
-            <a:r>
-              <a:rPr sz="850" b="0" i="1" dirty="0" err="1">
-                <a:solidFill>
-                  <a:srgbClr val="6B7280"/>
-                </a:solidFill>
-                <a:latin typeface="Arial"/>
-              </a:rPr>
-              <a:t>servizi</a:t>
-            </a:r>
-            <a:r>
-              <a:rPr sz="850" b="0" i="1" dirty="0">
-                <a:solidFill>
-                  <a:srgbClr val="6B7280"/>
-                </a:solidFill>
-                <a:latin typeface="Arial"/>
-              </a:rPr>
-              <a:t> </a:t>
-            </a:r>
-            <a:r>
-              <a:rPr sz="850" b="0" i="1" dirty="0" err="1">
-                <a:solidFill>
-                  <a:srgbClr val="6B7280"/>
-                </a:solidFill>
-                <a:latin typeface="Arial"/>
-              </a:rPr>
-              <a:t>che</a:t>
-            </a:r>
-            <a:r>
-              <a:rPr sz="850" b="0" i="1" dirty="0">
-                <a:solidFill>
-                  <a:srgbClr val="6B7280"/>
-                </a:solidFill>
-                <a:latin typeface="Arial"/>
-              </a:rPr>
-              <a:t> </a:t>
-            </a:r>
-            <a:r>
-              <a:rPr sz="850" b="0" i="1" dirty="0" err="1">
-                <a:solidFill>
-                  <a:srgbClr val="6B7280"/>
-                </a:solidFill>
-                <a:latin typeface="Arial"/>
-              </a:rPr>
-              <a:t>chiamano</a:t>
-            </a:r>
-            <a:r>
-              <a:rPr sz="850" b="0" i="1" dirty="0">
-                <a:solidFill>
-                  <a:srgbClr val="6B7280"/>
-                </a:solidFill>
-                <a:latin typeface="Arial"/>
-              </a:rPr>
-              <a:t> e </a:t>
-            </a:r>
-            <a:r>
-              <a:rPr sz="850" b="0" i="1" dirty="0" err="1">
-                <a:solidFill>
-                  <a:srgbClr val="6B7280"/>
-                </a:solidFill>
-                <a:latin typeface="Arial"/>
-              </a:rPr>
-              <a:t>i</a:t>
-            </a:r>
-            <a:r>
-              <a:rPr sz="850" b="0" i="1" dirty="0">
-                <a:solidFill>
-                  <a:srgbClr val="6B7280"/>
-                </a:solidFill>
-                <a:latin typeface="Arial"/>
-              </a:rPr>
-              <a:t> </a:t>
-            </a:r>
-            <a:r>
-              <a:rPr sz="850" b="0" i="1" dirty="0" err="1">
-                <a:solidFill>
-                  <a:srgbClr val="6B7280"/>
-                </a:solidFill>
-                <a:latin typeface="Arial"/>
-              </a:rPr>
-              <a:t>cambi</a:t>
-            </a:r>
-            <a:r>
-              <a:rPr sz="850" b="0" i="1" dirty="0">
-                <a:solidFill>
-                  <a:srgbClr val="6B7280"/>
-                </a:solidFill>
-                <a:latin typeface="Arial"/>
-              </a:rPr>
-              <a:t> di </a:t>
-            </a:r>
-            <a:r>
-              <a:rPr sz="850" b="0" i="1" dirty="0" err="1">
-                <a:solidFill>
-                  <a:srgbClr val="6B7280"/>
-                </a:solidFill>
-                <a:latin typeface="Arial"/>
-              </a:rPr>
-              <a:t>stato</a:t>
-            </a:r>
-            <a:r>
-              <a:rPr sz="850" b="0" i="1" dirty="0">
-                <a:solidFill>
-                  <a:srgbClr val="6B7280"/>
-                </a:solidFill>
-                <a:latin typeface="Arial"/>
-              </a:rPr>
-              <a:t> </a:t>
-            </a:r>
-            <a:r>
-              <a:rPr sz="850" b="0" i="1" dirty="0" err="1">
-                <a:solidFill>
-                  <a:srgbClr val="6B7280"/>
-                </a:solidFill>
-                <a:latin typeface="Arial"/>
-              </a:rPr>
-              <a:t>dell’atto</a:t>
-            </a:r>
-            <a:r>
-              <a:rPr sz="850" b="0" i="1" dirty="0">
-                <a:solidFill>
-                  <a:srgbClr val="6B7280"/>
-                </a:solidFill>
-                <a:latin typeface="Arial"/>
-              </a:rPr>
-              <a:t> in ANSC (ANSC_11) e in SIPO (ID_STATO_PRATICA)</a:t>
+              <a:t>Le pagine di SIPO, i servizi che chiamano e i cambi di stato dell’atto in ANSC (ANSC_11) e in SIPO (ID_STATO_PRATICA)</a:t>
             </a:r>
           </a:p>
         </p:txBody>
@@ -3426,7 +3192,7 @@
           <a:p>
             <a:pPr algn="ctr"/>
             <a:r>
-              <a:rPr sz="900" b="1" i="0">
+              <a:rPr lang="it-IT" sz="900" b="1" i="0" noProof="0" dirty="0">
                 <a:solidFill>
                   <a:srgbClr val="1F2937"/>
                 </a:solidFill>
@@ -3496,38 +3262,14 @@
           <a:p>
             <a:pPr algn="ctr"/>
             <a:r>
-              <a:rPr sz="900" b="1" i="0" dirty="0">
+              <a:rPr lang="it-IT" sz="900" b="1" i="0" noProof="0" dirty="0">
                 <a:solidFill>
                   <a:srgbClr val="1F2937"/>
                 </a:solidFill>
                 <a:latin typeface="Arial"/>
               </a:rPr>
-              <a:t>Servizio </a:t>
-            </a:r>
-            <a:r>
-              <a:rPr sz="900" b="1" i="0" dirty="0" err="1">
-                <a:solidFill>
-                  <a:srgbClr val="1F2937"/>
-                </a:solidFill>
-                <a:latin typeface="Arial"/>
-              </a:rPr>
-              <a:t>chiamato</a:t>
-            </a:r>
-            <a:r>
-              <a:rPr lang="it-IT" sz="900" b="1" i="0" dirty="0">
-                <a:solidFill>
-                  <a:srgbClr val="1F2937"/>
-                </a:solidFill>
-                <a:latin typeface="Arial"/>
-              </a:rPr>
-              <a:t> o servizi SIPO</a:t>
-            </a:r>
-            <a:endParaRPr sz="900" b="1" i="0" dirty="0">
-              <a:solidFill>
-                <a:srgbClr val="1F2937"/>
-              </a:solidFill>
-              <a:latin typeface="Arial"/>
-            </a:endParaRPr>
+              <a:t>Servizio chiamato o servizi SIPO</a:t>
+            </a:r>
           </a:p>
         </p:txBody>
       </p:sp>
@@ -3590,7 +3332,7 @@
           <a:p>
             <a:pPr algn="ctr"/>
             <a:r>
-              <a:rPr sz="900" b="1" i="0">
+              <a:rPr lang="it-IT" sz="900" b="1" i="0" noProof="0" dirty="0">
                 <a:solidFill>
                   <a:srgbClr val="1F2937"/>
                 </a:solidFill>
@@ -3660,7 +3402,7 @@
           <a:p>
             <a:pPr algn="ctr"/>
             <a:r>
-              <a:rPr sz="900" b="1" i="0">
+              <a:rPr lang="it-IT" sz="900" b="1" i="0" noProof="0" dirty="0">
                 <a:solidFill>
                   <a:srgbClr val="1F2937"/>
                 </a:solidFill>
@@ -3752,7 +3494,7 @@
           <a:p>
             <a:pPr algn="ctr"/>
             <a:r>
-              <a:rPr sz="900" b="1">
+              <a:rPr lang="it-IT" sz="900" b="1" noProof="0" dirty="0">
                 <a:solidFill>
                   <a:srgbClr val="1F2937"/>
                 </a:solidFill>
@@ -3764,7 +3506,7 @@
           <a:p>
             <a:pPr algn="ctr"/>
             <a:r>
-              <a:rPr sz="700" b="0">
+              <a:rPr lang="it-IT" sz="700" b="0" noProof="0" dirty="0">
                 <a:solidFill>
                   <a:srgbClr val="6B7280"/>
                 </a:solidFill>
@@ -3821,101 +3563,26 @@
           <a:p>
             <a:pPr algn="ctr"/>
             <a:r>
-              <a:rPr lang="it-IT" sz="900" b="1" dirty="0">
+              <a:rPr lang="it-IT" sz="900" b="1" noProof="0" dirty="0">
                 <a:solidFill>
                   <a:srgbClr val="1F2937"/>
                 </a:solidFill>
                 <a:latin typeface="Arial"/>
               </a:rPr>
-              <a:t>Ricerca d</a:t>
-            </a:r>
-            <a:r>
-              <a:rPr sz="900" b="1" dirty="0" err="1">
-                <a:solidFill>
-                  <a:srgbClr val="1F2937"/>
-                </a:solidFill>
-                <a:latin typeface="Arial"/>
-              </a:rPr>
-              <a:t>ati</a:t>
-            </a:r>
-            <a:r>
-              <a:rPr sz="900" b="1" dirty="0">
-                <a:solidFill>
-                  <a:srgbClr val="1F2937"/>
-                </a:solidFill>
-                <a:latin typeface="Arial"/>
-              </a:rPr>
-              <a:t> </a:t>
-            </a:r>
-            <a:r>
-              <a:rPr sz="900" b="1" dirty="0" err="1">
-                <a:solidFill>
-                  <a:srgbClr val="1F2937"/>
-                </a:solidFill>
-                <a:latin typeface="Arial"/>
-              </a:rPr>
-              <a:t>anagrafici</a:t>
-            </a:r>
-            <a:endParaRPr sz="900" b="1" dirty="0">
-              <a:solidFill>
-                <a:srgbClr val="1F2937"/>
-              </a:solidFill>
-              <a:latin typeface="Arial"/>
-            </a:endParaRPr>
+              <a:t>Ricerca dati anagrafici</a:t>
+            </a:r>
           </a:p>
           <a:p>
             <a:pPr algn="ctr"/>
             <a:r>
-              <a:rPr sz="700" b="0" dirty="0" err="1">
+              <a:rPr lang="it-IT" sz="700" b="0" noProof="0" dirty="0">
                 <a:solidFill>
                   <a:srgbClr val="6B7280"/>
                 </a:solidFill>
                 <a:latin typeface="Arial"/>
               </a:rPr>
-              <a:t>soggetti</a:t>
-            </a:r>
-            <a:r>
-              <a:rPr sz="700" b="0" dirty="0">
-                <a:solidFill>
-                  <a:srgbClr val="6B7280"/>
-                </a:solidFill>
-                <a:latin typeface="Arial"/>
-              </a:rPr>
-              <a:t> e </a:t>
-            </a:r>
-            <a:r>
-              <a:rPr sz="700" b="0" dirty="0" err="1">
-                <a:solidFill>
-                  <a:srgbClr val="6B7280"/>
-                </a:solidFill>
-                <a:latin typeface="Arial"/>
-              </a:rPr>
-              <a:t>intestatario</a:t>
-            </a:r>
-            <a:r>
-              <a:rPr sz="700" b="0" dirty="0">
-                <a:solidFill>
-                  <a:srgbClr val="6B7280"/>
-                </a:solidFill>
-                <a:latin typeface="Arial"/>
-              </a:rPr>
-              <a:t> </a:t>
-            </a:r>
-            <a:r>
-              <a:rPr lang="it-IT" sz="700" b="0" dirty="0">
-                <a:solidFill>
-                  <a:srgbClr val="6B7280"/>
-                </a:solidFill>
-                <a:latin typeface="Arial"/>
-              </a:rPr>
-              <a:t>da anagrafe locale SIPO</a:t>
-            </a:r>
-            <a:endParaRPr sz="700" b="0" dirty="0">
-              <a:solidFill>
-                <a:srgbClr val="6B7280"/>
-              </a:solidFill>
-              <a:latin typeface="Arial"/>
-            </a:endParaRPr>
+              <a:t>soggetti e intestatario da anagrafe locale SIPO</a:t>
+            </a:r>
           </a:p>
         </p:txBody>
       </p:sp>
@@ -3963,7 +3630,7 @@
           <a:p>
             <a:pPr algn="ctr"/>
             <a:r>
-              <a:rPr lang="it-IT" sz="750" dirty="0">
+              <a:rPr lang="it-IT" sz="750" noProof="0" dirty="0">
                 <a:solidFill>
                   <a:srgbClr val="1F2937"/>
                 </a:solidFill>
@@ -3971,7 +3638,7 @@
               </a:rPr>
               <a:t>Anagrafe Locale SIPO</a:t>
             </a:r>
-            <a:endParaRPr sz="750" b="0" dirty="0">
+            <a:endParaRPr lang="it-IT" sz="750" b="0" noProof="0" dirty="0">
               <a:solidFill>
                 <a:srgbClr val="1F2937"/>
               </a:solidFill>
@@ -4065,7 +3732,7 @@
           <a:p>
             <a:pPr algn="ctr"/>
             <a:r>
-              <a:rPr lang="it-IT" sz="900" b="1" dirty="0">
+              <a:rPr lang="it-IT" sz="900" b="1" noProof="0" dirty="0">
                 <a:solidFill>
                   <a:srgbClr val="1F2937"/>
                 </a:solidFill>
@@ -4077,182 +3744,14 @@
           <a:p>
             <a:pPr algn="ctr"/>
             <a:r>
-              <a:rPr sz="700" b="0" dirty="0" err="1">
+              <a:rPr lang="it-IT" sz="700" b="0" noProof="0" dirty="0">
                 <a:solidFill>
                   <a:srgbClr val="6B7280"/>
                 </a:solidFill>
                 <a:latin typeface="Arial"/>
               </a:rPr>
-              <a:t>i</a:t>
-            </a:r>
-            <a:r>
-              <a:rPr sz="700" b="0" dirty="0">
-                <a:solidFill>
-                  <a:srgbClr val="6B7280"/>
-                </a:solidFill>
-                <a:latin typeface="Arial"/>
-              </a:rPr>
-              <a:t> </a:t>
-            </a:r>
-            <a:r>
-              <a:rPr sz="700" b="0" dirty="0" err="1">
-                <a:solidFill>
-                  <a:srgbClr val="6B7280"/>
-                </a:solidFill>
-                <a:latin typeface="Arial"/>
-              </a:rPr>
-              <a:t>tre</a:t>
-            </a:r>
-            <a:r>
-              <a:rPr sz="700" b="0" dirty="0">
-                <a:solidFill>
-                  <a:srgbClr val="6B7280"/>
-                </a:solidFill>
-                <a:latin typeface="Arial"/>
-              </a:rPr>
-              <a:t> </a:t>
-            </a:r>
-            <a:r>
-              <a:rPr sz="700" b="0" dirty="0" err="1">
-                <a:solidFill>
-                  <a:srgbClr val="6B7280"/>
-                </a:solidFill>
-                <a:latin typeface="Arial"/>
-              </a:rPr>
-              <a:t>codici</a:t>
-            </a:r>
-            <a:r>
-              <a:rPr sz="700" b="0" dirty="0">
-                <a:solidFill>
-                  <a:srgbClr val="6B7280"/>
-                </a:solidFill>
-                <a:latin typeface="Arial"/>
-              </a:rPr>
-              <a:t> </a:t>
-            </a:r>
-            <a:r>
-              <a:rPr lang="it-IT" sz="700" b="0" dirty="0">
-                <a:solidFill>
-                  <a:srgbClr val="6B7280"/>
-                </a:solidFill>
-                <a:latin typeface="Arial"/>
-              </a:rPr>
-              <a:t> identificativi </a:t>
-            </a:r>
-            <a:r>
-              <a:rPr sz="700" b="0" dirty="0">
-                <a:solidFill>
-                  <a:srgbClr val="6B7280"/>
-                </a:solidFill>
-                <a:latin typeface="Arial"/>
-              </a:rPr>
-              <a:t>per </a:t>
-            </a:r>
-            <a:r>
-              <a:rPr sz="700" b="0" dirty="0" err="1">
-                <a:solidFill>
-                  <a:srgbClr val="6B7280"/>
-                </a:solidFill>
-                <a:latin typeface="Arial"/>
-              </a:rPr>
-              <a:t>soggetto</a:t>
-            </a:r>
-            <a:r>
-              <a:rPr sz="700" b="0" dirty="0">
-                <a:solidFill>
-                  <a:srgbClr val="6B7280"/>
-                </a:solidFill>
-                <a:latin typeface="Arial"/>
-              </a:rPr>
-              <a:t>; non </a:t>
-            </a:r>
-            <a:r>
-              <a:rPr sz="700" b="0" dirty="0" err="1">
-                <a:solidFill>
-                  <a:srgbClr val="6B7280"/>
-                </a:solidFill>
-                <a:latin typeface="Arial"/>
-              </a:rPr>
-              <a:t>si</a:t>
-            </a:r>
-            <a:r>
-              <a:rPr sz="700" b="0" dirty="0">
-                <a:solidFill>
-                  <a:srgbClr val="6B7280"/>
-                </a:solidFill>
-                <a:latin typeface="Arial"/>
-              </a:rPr>
-              <a:t> </a:t>
-            </a:r>
-            <a:r>
-              <a:rPr sz="700" b="0" dirty="0" err="1">
-                <a:solidFill>
-                  <a:srgbClr val="6B7280"/>
-                </a:solidFill>
-                <a:latin typeface="Arial"/>
-              </a:rPr>
-              <a:t>prosegue</a:t>
-            </a:r>
-            <a:r>
-              <a:rPr sz="700" b="0" dirty="0">
-                <a:solidFill>
-                  <a:srgbClr val="6B7280"/>
-                </a:solidFill>
-                <a:latin typeface="Arial"/>
-              </a:rPr>
-              <a:t> se </a:t>
-            </a:r>
-            <a:r>
-              <a:rPr sz="700" b="0" dirty="0" err="1">
-                <a:solidFill>
-                  <a:srgbClr val="6B7280"/>
-                </a:solidFill>
-                <a:latin typeface="Arial"/>
-              </a:rPr>
-              <a:t>mancano</a:t>
-            </a:r>
-            <a:r>
-              <a:rPr sz="700" b="0" dirty="0">
-                <a:solidFill>
-                  <a:srgbClr val="6B7280"/>
-                </a:solidFill>
-                <a:latin typeface="Arial"/>
-              </a:rPr>
-              <a:t> </a:t>
-            </a:r>
-            <a:r>
-              <a:rPr sz="700" b="0" dirty="0" err="1">
-                <a:solidFill>
-                  <a:srgbClr val="6B7280"/>
-                </a:solidFill>
-                <a:latin typeface="Arial"/>
-              </a:rPr>
-              <a:t>dati</a:t>
-            </a:r>
-            <a:r>
-              <a:rPr sz="700" b="0" dirty="0">
-                <a:solidFill>
-                  <a:srgbClr val="6B7280"/>
-                </a:solidFill>
-                <a:latin typeface="Arial"/>
-              </a:rPr>
-              <a:t> </a:t>
-            </a:r>
-            <a:r>
-              <a:rPr sz="700" b="0" dirty="0" err="1">
-                <a:solidFill>
-                  <a:srgbClr val="6B7280"/>
-                </a:solidFill>
-                <a:latin typeface="Arial"/>
-              </a:rPr>
-              <a:t>obbligatori</a:t>
-            </a:r>
-            <a:endParaRPr sz="700" b="0" dirty="0">
-              <a:solidFill>
-                <a:srgbClr val="6B7280"/>
-              </a:solidFill>
-              <a:latin typeface="Arial"/>
-            </a:endParaRPr>
+              <a:t>i tre codici  identificativi per soggetto; non si prosegue se mancano dati obbligatori</a:t>
+            </a:r>
           </a:p>
         </p:txBody>
       </p:sp>
@@ -4300,64 +3799,31 @@
           <a:p>
             <a:pPr algn="ctr"/>
             <a:r>
-              <a:rPr sz="750" b="0" dirty="0">
+              <a:rPr lang="it-IT" sz="750" b="0" noProof="0" dirty="0">
                 <a:solidFill>
                   <a:srgbClr val="1F2937"/>
                 </a:solidFill>
                 <a:latin typeface="Arial"/>
               </a:rPr>
-              <a:t>R005 · per </a:t>
-            </a:r>
-            <a:r>
-              <a:rPr sz="750" b="0" dirty="0" err="1">
+              <a:t>R005 · per ciascun soggetto</a:t>
+            </a:r>
+            <a:br>
+              <a:rPr lang="it-IT" sz="750" b="0" noProof="0" dirty="0">
                 <a:solidFill>
                   <a:srgbClr val="1F2937"/>
                 </a:solidFill>
                 <a:latin typeface="Arial"/>
               </a:rPr>
-              <a:t>ciascun</a:t>
-            </a:r>
-            <a:r>
-              <a:rPr sz="750" b="0" dirty="0">
+            </a:br>
+            <a:r>
+              <a:rPr lang="it-IT" sz="750" b="0" noProof="0" dirty="0">
                 <a:solidFill>
                   <a:srgbClr val="1F2937"/>
                 </a:solidFill>
                 <a:latin typeface="Arial"/>
               </a:rPr>
-              <a:t> </a:t>
-            </a:r>
-            <a:r>
-              <a:rPr sz="750" b="0" dirty="0" err="1">
-                <a:solidFill>
-                  <a:srgbClr val="1F2937"/>
-                </a:solidFill>
-                <a:latin typeface="Arial"/>
-              </a:rPr>
-              <a:t>soggetto</a:t>
-            </a:r>
-            <a:br>
-              <a:rPr lang="it-IT" sz="750" b="0" dirty="0">
-                <a:solidFill>
-                  <a:srgbClr val="1F2937"/>
-                </a:solidFill>
-                <a:latin typeface="Arial"/>
-              </a:rPr>
-            </a:br>
-            <a:r>
-              <a:rPr lang="it-IT" sz="750" b="0" dirty="0">
-                <a:solidFill>
-                  <a:srgbClr val="1F2937"/>
-                </a:solidFill>
-                <a:latin typeface="Arial"/>
-              </a:rPr>
               <a:t>obbligatoria la chiamata R005 per passare pagina</a:t>
             </a:r>
-            <a:endParaRPr sz="750" b="0" dirty="0">
-              <a:solidFill>
-                <a:srgbClr val="1F2937"/>
-              </a:solidFill>
-              <a:latin typeface="Arial"/>
-            </a:endParaRPr>
           </a:p>
         </p:txBody>
       </p:sp>
@@ -4446,28 +3912,19 @@
           <a:p>
             <a:pPr algn="ctr"/>
             <a:r>
-              <a:rPr sz="900" b="1" dirty="0" err="1">
+              <a:rPr lang="it-IT" sz="900" b="1" noProof="0" dirty="0">
                 <a:solidFill>
                   <a:srgbClr val="1F2937"/>
                 </a:solidFill>
                 <a:latin typeface="Arial"/>
               </a:rPr>
-              <a:t>Riepilogo</a:t>
-            </a:r>
-            <a:r>
-              <a:rPr lang="it-IT" sz="900" b="1" dirty="0">
-                <a:solidFill>
-                  <a:srgbClr val="1F2937"/>
-                </a:solidFill>
-                <a:latin typeface="Arial"/>
-              </a:rPr>
-              <a:t> Atto</a:t>
+              <a:t>Riepilogo Atto</a:t>
             </a:r>
           </a:p>
           <a:p>
             <a:pPr algn="ctr"/>
             <a:r>
-              <a:rPr lang="it-IT" sz="700" dirty="0">
+              <a:rPr lang="it-IT" sz="700" noProof="0" dirty="0">
                 <a:solidFill>
                   <a:srgbClr val="6B7280"/>
                 </a:solidFill>
@@ -4475,7 +3932,7 @@
               </a:rPr>
               <a:t>Recupero/Individuazione codice UC</a:t>
             </a:r>
-            <a:endParaRPr lang="it-IT" sz="700" b="1" dirty="0">
+            <a:endParaRPr lang="it-IT" sz="700" b="1" noProof="0" dirty="0">
               <a:solidFill>
                 <a:srgbClr val="1F2937"/>
               </a:solidFill>
@@ -4485,7 +3942,7 @@
           <a:p>
             <a:pPr algn="ctr"/>
             <a:r>
-              <a:rPr lang="it-IT" sz="800" dirty="0">
+              <a:rPr lang="it-IT" sz="800" noProof="0" dirty="0">
                 <a:solidFill>
                   <a:srgbClr val="1F2937"/>
                 </a:solidFill>
@@ -4493,7 +3950,7 @@
               </a:rPr>
               <a:t>Elaborazione dati e predisposizione Atto SIPO</a:t>
             </a:r>
-            <a:endParaRPr sz="900" b="1" dirty="0">
+            <a:endParaRPr lang="it-IT" sz="900" b="1" noProof="0" dirty="0">
               <a:solidFill>
                 <a:srgbClr val="1F2937"/>
               </a:solidFill>
@@ -4503,69 +3960,24 @@
           <a:p>
             <a:pPr algn="ctr"/>
             <a:r>
-              <a:rPr sz="700" b="0" dirty="0" err="1">
+              <a:rPr lang="it-IT" sz="700" b="0" noProof="0" dirty="0">
                 <a:solidFill>
                   <a:srgbClr val="6B7280"/>
                 </a:solidFill>
                 <a:latin typeface="Arial"/>
               </a:rPr>
-              <a:t>firmatari</a:t>
-            </a:r>
-            <a:r>
-              <a:rPr sz="700" b="0" dirty="0">
+              <a:t>firmatari, eventuali dati mancanti</a:t>
+            </a:r>
+            <a:r>
+              <a:rPr lang="it-IT" sz="700" noProof="0" dirty="0">
                 <a:solidFill>
                   <a:srgbClr val="6B7280"/>
                 </a:solidFill>
                 <a:latin typeface="Arial"/>
               </a:rPr>
-              <a:t>, </a:t>
-            </a:r>
-            <a:r>
-              <a:rPr lang="it-IT" sz="700" b="0" dirty="0">
-                <a:solidFill>
-                  <a:srgbClr val="6B7280"/>
-                </a:solidFill>
-                <a:latin typeface="Arial"/>
-              </a:rPr>
-              <a:t>eventuali </a:t>
-            </a:r>
-            <a:r>
-              <a:rPr sz="700" b="0" dirty="0" err="1">
-                <a:solidFill>
-                  <a:srgbClr val="6B7280"/>
-                </a:solidFill>
-                <a:latin typeface="Arial"/>
-              </a:rPr>
-              <a:t>dati</a:t>
-            </a:r>
-            <a:r>
-              <a:rPr sz="700" b="0" dirty="0">
-                <a:solidFill>
-                  <a:srgbClr val="6B7280"/>
-                </a:solidFill>
-                <a:latin typeface="Arial"/>
-              </a:rPr>
-              <a:t> </a:t>
-            </a:r>
-            <a:r>
-              <a:rPr sz="700" b="0" dirty="0" err="1">
-                <a:solidFill>
-                  <a:srgbClr val="6B7280"/>
-                </a:solidFill>
-                <a:latin typeface="Arial"/>
-              </a:rPr>
-              <a:t>mancanti</a:t>
-            </a:r>
-            <a:r>
-              <a:rPr lang="it-IT" sz="700" dirty="0">
-                <a:solidFill>
-                  <a:srgbClr val="6B7280"/>
-                </a:solidFill>
-                <a:latin typeface="Arial"/>
-              </a:rPr>
               <a:t>, allegati</a:t>
             </a:r>
-            <a:endParaRPr sz="700" b="0" dirty="0">
+            <a:endParaRPr lang="it-IT" sz="700" b="0" noProof="0" dirty="0">
               <a:solidFill>
                 <a:srgbClr val="6B7280"/>
               </a:solidFill>
@@ -4618,7 +4030,7 @@
           <a:p>
             <a:pPr algn="ctr"/>
             <a:r>
-              <a:rPr lang="it-IT" sz="750" b="0" dirty="0">
+              <a:rPr lang="it-IT" sz="750" b="0" noProof="0" dirty="0">
                 <a:solidFill>
                   <a:srgbClr val="1F2937"/>
                 </a:solidFill>
@@ -4627,7 +4039,7 @@
               <a:t>Eventuale </a:t>
             </a:r>
             <a:r>
-              <a:rPr lang="it-IT" sz="750" b="0" dirty="0" err="1">
+              <a:rPr lang="it-IT" sz="750" b="0" noProof="0" dirty="0" err="1">
                 <a:solidFill>
                   <a:srgbClr val="1F2937"/>
                 </a:solidFill>
@@ -4636,7 +4048,7 @@
               <a:t>preverifica</a:t>
             </a:r>
             <a:r>
-              <a:rPr lang="it-IT" sz="750" b="0" dirty="0">
+              <a:rPr lang="it-IT" sz="750" b="0" noProof="0" dirty="0">
                 <a:solidFill>
                   <a:srgbClr val="1F2937"/>
                 </a:solidFill>
@@ -4644,12 +4056,6 @@
               </a:rPr>
               <a:t> vedere decodifica ANSC_03</a:t>
             </a:r>
-            <a:endParaRPr sz="750" b="0" dirty="0">
-              <a:solidFill>
-                <a:srgbClr val="1F2937"/>
-              </a:solidFill>
-              <a:latin typeface="Arial"/>
-            </a:endParaRPr>
           </a:p>
         </p:txBody>
       </p:sp>
@@ -4739,82 +4145,31 @@
           <a:p>
             <a:pPr algn="ctr"/>
             <a:r>
-              <a:rPr sz="900" b="1" dirty="0" err="1">
+              <a:rPr lang="it-IT" sz="900" b="1" noProof="0" dirty="0">
                 <a:solidFill>
                   <a:srgbClr val="1F2937"/>
                 </a:solidFill>
                 <a:latin typeface="Arial"/>
               </a:rPr>
-              <a:t>Anteprima</a:t>
-            </a:r>
-            <a:r>
-              <a:rPr lang="it-IT" sz="900" b="1" dirty="0">
+              <a:t>Anteprima SIPO</a:t>
+            </a:r>
+          </a:p>
+          <a:p>
+            <a:pPr algn="ctr"/>
+            <a:r>
+              <a:rPr lang="it-IT" sz="600" b="1" noProof="0" dirty="0">
                 <a:solidFill>
                   <a:srgbClr val="1F2937"/>
                 </a:solidFill>
                 <a:latin typeface="Arial"/>
               </a:rPr>
-              <a:t> SIPO</a:t>
+              <a:t>Serve il numero comunale</a:t>
             </a:r>
           </a:p>
           <a:p>
             <a:pPr algn="ctr"/>
             <a:r>
-              <a:rPr lang="it-IT" sz="600" b="1" dirty="0">
-                <a:solidFill>
-                  <a:srgbClr val="1F2937"/>
-                </a:solidFill>
-                <a:latin typeface="Arial"/>
-              </a:rPr>
-              <a:t>Serve il</a:t>
-            </a:r>
-            <a:r>
-              <a:rPr sz="600" b="1" dirty="0">
-                <a:solidFill>
-                  <a:srgbClr val="1F2937"/>
-                </a:solidFill>
-                <a:latin typeface="Arial"/>
-              </a:rPr>
-              <a:t> </a:t>
-            </a:r>
-            <a:r>
-              <a:rPr sz="600" b="1" dirty="0" err="1">
-                <a:solidFill>
-                  <a:srgbClr val="1F2937"/>
-                </a:solidFill>
-                <a:latin typeface="Arial"/>
-              </a:rPr>
-              <a:t>numero</a:t>
-            </a:r>
-            <a:r>
-              <a:rPr sz="600" b="1" dirty="0">
-                <a:solidFill>
-                  <a:srgbClr val="1F2937"/>
-                </a:solidFill>
-                <a:latin typeface="Arial"/>
-              </a:rPr>
-              <a:t> </a:t>
-            </a:r>
-            <a:r>
-              <a:rPr sz="600" b="1" dirty="0" err="1">
-                <a:solidFill>
-                  <a:srgbClr val="1F2937"/>
-                </a:solidFill>
-                <a:latin typeface="Arial"/>
-              </a:rPr>
-              <a:t>comunale</a:t>
-            </a:r>
-            <a:endParaRPr sz="600" b="1" dirty="0">
-              <a:solidFill>
-                <a:srgbClr val="1F2937"/>
-              </a:solidFill>
-              <a:latin typeface="Arial"/>
-            </a:endParaRPr>
-          </a:p>
-          <a:p>
-            <a:pPr algn="ctr"/>
-            <a:r>
-              <a:rPr lang="it-IT" sz="700" b="0" dirty="0" err="1">
+              <a:rPr lang="it-IT" sz="700" b="0" noProof="0" dirty="0" err="1">
                 <a:solidFill>
                   <a:srgbClr val="6B7280"/>
                 </a:solidFill>
@@ -4823,7 +4178,7 @@
               <a:t>Costruiisce</a:t>
             </a:r>
             <a:r>
-              <a:rPr lang="it-IT" sz="700" b="0" dirty="0">
+              <a:rPr lang="it-IT" sz="700" b="0" noProof="0" dirty="0">
                 <a:solidFill>
                   <a:srgbClr val="6B7280"/>
                 </a:solidFill>
@@ -4832,7 +4187,7 @@
               <a:t> il testo dell’atto </a:t>
             </a:r>
             <a:br>
-              <a:rPr lang="it-IT" sz="700" b="0" dirty="0">
+              <a:rPr lang="it-IT" sz="700" b="0" noProof="0" dirty="0">
                 <a:solidFill>
                   <a:srgbClr val="6B7280"/>
                 </a:solidFill>
@@ -4840,7 +4195,7 @@
               </a:rPr>
             </a:br>
             <a:r>
-              <a:rPr lang="it-IT" sz="700" b="0" dirty="0">
+              <a:rPr lang="it-IT" sz="700" b="0" noProof="0" dirty="0">
                 <a:solidFill>
                   <a:srgbClr val="6B7280"/>
                 </a:solidFill>
@@ -4848,12 +4203,6 @@
               </a:rPr>
               <a:t>Inserire bottone VALIDA</a:t>
             </a:r>
-            <a:endParaRPr sz="700" b="0" dirty="0">
-              <a:solidFill>
-                <a:srgbClr val="6B7280"/>
-              </a:solidFill>
-              <a:latin typeface="Arial"/>
-            </a:endParaRPr>
           </a:p>
         </p:txBody>
       </p:sp>
@@ -4901,13 +4250,31 @@
           <a:p>
             <a:pPr algn="ctr"/>
             <a:r>
-              <a:rPr lang="it-IT" sz="800" dirty="0">
+              <a:rPr lang="it-IT" sz="800" noProof="0" dirty="0">
                 <a:solidFill>
                   <a:schemeClr val="tx1"/>
                 </a:solidFill>
                 <a:latin typeface="Arial"/>
               </a:rPr>
-              <a:t>Obbligatoria utenza, PIN e OTP del servizio di firma remota</a:t>
+              <a:t>Obbligatoria utenza e </a:t>
+            </a:r>
+            <a:r>
+              <a:rPr lang="it-IT" sz="800" noProof="0" dirty="0" err="1">
+                <a:solidFill>
+                  <a:schemeClr val="tx1"/>
+                </a:solidFill>
+                <a:latin typeface="Arial"/>
+              </a:rPr>
+              <a:t>disponibillità</a:t>
+            </a:r>
+            <a:r>
+              <a:rPr lang="it-IT" sz="800" noProof="0" dirty="0">
+                <a:solidFill>
+                  <a:schemeClr val="tx1"/>
+                </a:solidFill>
+                <a:latin typeface="Arial"/>
+              </a:rPr>
+              <a:t> di PIN e OTP del servizio di firma remota</a:t>
             </a:r>
           </a:p>
         </p:txBody>
@@ -5001,189 +4368,60 @@
           <a:p>
             <a:pPr algn="ctr"/>
             <a:r>
-              <a:rPr sz="900" b="1" dirty="0" err="1">
+              <a:rPr lang="it-IT" sz="900" b="1" noProof="0" dirty="0">
                 <a:solidFill>
                   <a:srgbClr val="1F2937"/>
                 </a:solidFill>
                 <a:latin typeface="Arial"/>
               </a:rPr>
-              <a:t>Anteprima</a:t>
-            </a:r>
-            <a:r>
-              <a:rPr sz="900" b="1" dirty="0">
-                <a:solidFill>
-                  <a:srgbClr val="1F2937"/>
-                </a:solidFill>
-                <a:latin typeface="Arial"/>
-              </a:rPr>
-              <a:t> · Valida</a:t>
-            </a:r>
-            <a:r>
-              <a:rPr lang="it-IT" sz="900" b="1" dirty="0">
-                <a:solidFill>
-                  <a:srgbClr val="1F2937"/>
-                </a:solidFill>
-                <a:latin typeface="Arial"/>
-              </a:rPr>
-              <a:t>zione (nuova pagina)</a:t>
-            </a:r>
-            <a:endParaRPr sz="900" b="1" dirty="0">
-              <a:solidFill>
-                <a:srgbClr val="1F2937"/>
-              </a:solidFill>
-              <a:latin typeface="Arial"/>
-            </a:endParaRPr>
+              <a:t>Anteprima · Validazione (nuova pagina)</a:t>
+            </a:r>
           </a:p>
           <a:p>
             <a:pPr algn="ctr"/>
             <a:r>
-              <a:rPr sz="700" b="0" dirty="0" err="1">
+              <a:rPr lang="it-IT" sz="700" b="0" noProof="0" dirty="0">
                 <a:solidFill>
                   <a:srgbClr val="6B7280"/>
                 </a:solidFill>
                 <a:latin typeface="Arial"/>
               </a:rPr>
-              <a:t>validazione</a:t>
-            </a:r>
-            <a:r>
-              <a:rPr sz="700" b="0" dirty="0">
+              <a:t>validazione di metadati e allegati; si salvano gli idAnsc</a:t>
+            </a:r>
+            <a:br>
+              <a:rPr lang="it-IT" sz="700" b="0" noProof="0" dirty="0">
                 <a:solidFill>
                   <a:srgbClr val="6B7280"/>
                 </a:solidFill>
                 <a:latin typeface="Arial"/>
               </a:rPr>
-              <a:t> di </a:t>
-            </a:r>
-            <a:r>
-              <a:rPr sz="700" b="0" dirty="0" err="1">
+            </a:br>
+            <a:r>
+              <a:rPr lang="it-IT" sz="700" b="0" noProof="0" dirty="0">
                 <a:solidFill>
                   <a:srgbClr val="6B7280"/>
                 </a:solidFill>
                 <a:latin typeface="Arial"/>
               </a:rPr>
-              <a:t>metadati</a:t>
-            </a:r>
-            <a:r>
-              <a:rPr sz="700" b="0" dirty="0">
+              <a:t>Preparazione Payload + Invio R009</a:t>
+            </a:r>
+            <a:br>
+              <a:rPr lang="it-IT" sz="700" b="0" noProof="0" dirty="0">
                 <a:solidFill>
                   <a:srgbClr val="6B7280"/>
                 </a:solidFill>
                 <a:latin typeface="Arial"/>
               </a:rPr>
-              <a:t> e </a:t>
-            </a:r>
-            <a:r>
-              <a:rPr sz="700" b="0" dirty="0" err="1">
+            </a:br>
+            <a:r>
+              <a:rPr lang="it-IT" sz="700" b="0" noProof="0" dirty="0">
                 <a:solidFill>
                   <a:srgbClr val="6B7280"/>
                 </a:solidFill>
                 <a:latin typeface="Arial"/>
               </a:rPr>
-              <a:t>allegati</a:t>
-            </a:r>
-            <a:r>
-              <a:rPr sz="700" b="0" dirty="0">
-                <a:solidFill>
-                  <a:srgbClr val="6B7280"/>
-                </a:solidFill>
-                <a:latin typeface="Arial"/>
-              </a:rPr>
-              <a:t>; </a:t>
-            </a:r>
-            <a:r>
-              <a:rPr sz="700" b="0" dirty="0" err="1">
-                <a:solidFill>
-                  <a:srgbClr val="6B7280"/>
-                </a:solidFill>
-                <a:latin typeface="Arial"/>
-              </a:rPr>
-              <a:t>si</a:t>
-            </a:r>
-            <a:r>
-              <a:rPr sz="700" b="0" dirty="0">
-                <a:solidFill>
-                  <a:srgbClr val="6B7280"/>
-                </a:solidFill>
-                <a:latin typeface="Arial"/>
-              </a:rPr>
-              <a:t> </a:t>
-            </a:r>
-            <a:r>
-              <a:rPr sz="700" b="0" dirty="0" err="1">
-                <a:solidFill>
-                  <a:srgbClr val="6B7280"/>
-                </a:solidFill>
-                <a:latin typeface="Arial"/>
-              </a:rPr>
-              <a:t>salvano</a:t>
-            </a:r>
-            <a:r>
-              <a:rPr sz="700" b="0" dirty="0">
-                <a:solidFill>
-                  <a:srgbClr val="6B7280"/>
-                </a:solidFill>
-                <a:latin typeface="Arial"/>
-              </a:rPr>
-              <a:t> </a:t>
-            </a:r>
-            <a:r>
-              <a:rPr sz="700" b="0" dirty="0" err="1">
-                <a:solidFill>
-                  <a:srgbClr val="6B7280"/>
-                </a:solidFill>
-                <a:latin typeface="Arial"/>
-              </a:rPr>
-              <a:t>gli</a:t>
-            </a:r>
-            <a:r>
-              <a:rPr sz="700" b="0" dirty="0">
-                <a:solidFill>
-                  <a:srgbClr val="6B7280"/>
-                </a:solidFill>
-                <a:latin typeface="Arial"/>
-              </a:rPr>
-              <a:t> idAnsc</a:t>
-            </a:r>
-            <a:br>
-              <a:rPr lang="it-IT" sz="700" b="0" dirty="0">
-                <a:solidFill>
-                  <a:srgbClr val="6B7280"/>
-                </a:solidFill>
-                <a:latin typeface="Arial"/>
-              </a:rPr>
-            </a:br>
-            <a:r>
-              <a:rPr lang="it-IT" sz="700" b="0" dirty="0">
-                <a:solidFill>
-                  <a:srgbClr val="6B7280"/>
-                </a:solidFill>
-                <a:latin typeface="Arial"/>
-              </a:rPr>
-              <a:t>Preparazione Payload + Invio R009</a:t>
-            </a:r>
-            <a:br>
-              <a:rPr lang="it-IT" sz="700" b="0" dirty="0">
-                <a:solidFill>
-                  <a:srgbClr val="6B7280"/>
-                </a:solidFill>
-                <a:latin typeface="Arial"/>
-              </a:rPr>
-            </a:br>
-            <a:r>
-              <a:rPr lang="it-IT" sz="700" b="0" dirty="0">
-                <a:solidFill>
-                  <a:srgbClr val="6B7280"/>
-                </a:solidFill>
-                <a:latin typeface="Arial"/>
-              </a:rPr>
-              <a:t>Gestione errori</a:t>
-            </a:r>
-            <a:endParaRPr sz="700" b="0" dirty="0">
-              <a:solidFill>
-                <a:srgbClr val="6B7280"/>
-              </a:solidFill>
-              <a:latin typeface="Arial"/>
-            </a:endParaRPr>
+              <a:t>Gestione errori e forzature</a:t>
+            </a:r>
           </a:p>
         </p:txBody>
       </p:sp>
@@ -5231,47 +4469,14 @@
           <a:p>
             <a:pPr algn="ctr"/>
             <a:r>
-              <a:rPr sz="750" b="0" dirty="0">
+              <a:rPr lang="it-IT" sz="750" b="0" noProof="0" dirty="0">
                 <a:solidFill>
                   <a:srgbClr val="1F2937"/>
                 </a:solidFill>
                 <a:latin typeface="Arial"/>
               </a:rPr>
-              <a:t>R009 /</a:t>
-            </a:r>
-            <a:r>
-              <a:rPr sz="750" b="0" dirty="0" err="1">
-                <a:solidFill>
-                  <a:srgbClr val="1F2937"/>
-                </a:solidFill>
-                <a:latin typeface="Arial"/>
-              </a:rPr>
-              <a:t>validazione</a:t>
-            </a:r>
-            <a:r>
-              <a:rPr sz="750" b="0" dirty="0">
-                <a:solidFill>
-                  <a:srgbClr val="1F2937"/>
-                </a:solidFill>
-                <a:latin typeface="Arial"/>
-              </a:rPr>
-              <a:t>/</a:t>
-            </a:r>
-            <a:r>
-              <a:rPr sz="750" b="0" dirty="0" err="1">
-                <a:solidFill>
-                  <a:srgbClr val="1F2937"/>
-                </a:solidFill>
-                <a:latin typeface="Arial"/>
-              </a:rPr>
-              <a:t>evento</a:t>
-            </a:r>
-            <a:endParaRPr sz="750" b="0" dirty="0">
-              <a:solidFill>
-                <a:srgbClr val="1F2937"/>
-              </a:solidFill>
-              <a:latin typeface="Arial"/>
-            </a:endParaRPr>
+              <a:t>R009 /validazione/evento</a:t>
+            </a:r>
           </a:p>
         </p:txBody>
       </p:sp>
@@ -5363,185 +4568,38 @@
           <a:p>
             <a:pPr algn="ctr"/>
             <a:r>
-              <a:rPr sz="900" b="1" dirty="0" err="1">
+              <a:rPr lang="it-IT" sz="900" b="1" noProof="0" dirty="0">
                 <a:solidFill>
                   <a:srgbClr val="1F2937"/>
                 </a:solidFill>
                 <a:latin typeface="Arial"/>
               </a:rPr>
-              <a:t>Anteprima</a:t>
-            </a:r>
-            <a:r>
-              <a:rPr sz="900" b="1" dirty="0">
+              <a:t>Anteprima · firme dei dichiaranti </a:t>
+            </a:r>
+          </a:p>
+          <a:p>
+            <a:pPr algn="ctr"/>
+            <a:r>
+              <a:rPr lang="it-IT" sz="900" b="1" noProof="0" dirty="0">
                 <a:solidFill>
                   <a:srgbClr val="1F2937"/>
                 </a:solidFill>
                 <a:latin typeface="Arial"/>
               </a:rPr>
-              <a:t> · </a:t>
-            </a:r>
-            <a:r>
-              <a:rPr sz="900" b="1" dirty="0" err="1">
-                <a:solidFill>
-                  <a:srgbClr val="1F2937"/>
-                </a:solidFill>
-                <a:latin typeface="Arial"/>
-              </a:rPr>
-              <a:t>firme</a:t>
-            </a:r>
-            <a:r>
-              <a:rPr sz="900" b="1" dirty="0">
-                <a:solidFill>
-                  <a:srgbClr val="1F2937"/>
-                </a:solidFill>
-                <a:latin typeface="Arial"/>
-              </a:rPr>
-              <a:t> </a:t>
-            </a:r>
-            <a:r>
-              <a:rPr sz="900" b="1" dirty="0" err="1">
-                <a:solidFill>
-                  <a:srgbClr val="1F2937"/>
-                </a:solidFill>
-                <a:latin typeface="Arial"/>
-              </a:rPr>
-              <a:t>dei</a:t>
-            </a:r>
-            <a:r>
-              <a:rPr sz="900" b="1" dirty="0">
-                <a:solidFill>
-                  <a:srgbClr val="1F2937"/>
-                </a:solidFill>
-                <a:latin typeface="Arial"/>
-              </a:rPr>
-              <a:t> </a:t>
-            </a:r>
-            <a:r>
-              <a:rPr sz="900" b="1" dirty="0" err="1">
-                <a:solidFill>
-                  <a:srgbClr val="1F2937"/>
-                </a:solidFill>
-                <a:latin typeface="Arial"/>
-              </a:rPr>
-              <a:t>dichiaranti</a:t>
-            </a:r>
-            <a:r>
-              <a:rPr lang="it-IT" sz="900" b="1" dirty="0">
-                <a:solidFill>
-                  <a:srgbClr val="1F2937"/>
-                </a:solidFill>
-                <a:latin typeface="Arial"/>
-              </a:rPr>
-              <a:t> </a:t>
+              <a:t>(nuova pagina)</a:t>
             </a:r>
           </a:p>
           <a:p>
             <a:pPr algn="ctr"/>
             <a:r>
-              <a:rPr lang="it-IT" sz="900" b="1" dirty="0">
-                <a:solidFill>
-                  <a:srgbClr val="1F2937"/>
-                </a:solidFill>
-                <a:latin typeface="Arial"/>
-              </a:rPr>
-              <a:t>(nuova pagina)</a:t>
-            </a:r>
-            <a:endParaRPr sz="900" b="1" dirty="0">
-              <a:solidFill>
-                <a:srgbClr val="1F2937"/>
-              </a:solidFill>
-              <a:latin typeface="Arial"/>
-            </a:endParaRPr>
-          </a:p>
-          <a:p>
-            <a:pPr algn="ctr"/>
-            <a:r>
-              <a:rPr sz="700" b="0" dirty="0" err="1">
+              <a:rPr lang="it-IT" sz="700" b="0" noProof="0" dirty="0">
                 <a:solidFill>
                   <a:srgbClr val="6B7280"/>
                 </a:solidFill>
                 <a:latin typeface="Arial"/>
               </a:rPr>
-              <a:t>firma</a:t>
-            </a:r>
-            <a:r>
-              <a:rPr sz="700" b="0" dirty="0">
-                <a:solidFill>
-                  <a:srgbClr val="6B7280"/>
-                </a:solidFill>
-                <a:latin typeface="Arial"/>
-              </a:rPr>
-              <a:t> </a:t>
-            </a:r>
-            <a:r>
-              <a:rPr sz="700" b="0" dirty="0" err="1">
-                <a:solidFill>
-                  <a:srgbClr val="6B7280"/>
-                </a:solidFill>
-                <a:latin typeface="Arial"/>
-              </a:rPr>
-              <a:t>digitale</a:t>
-            </a:r>
-            <a:r>
-              <a:rPr sz="700" b="0" dirty="0">
-                <a:solidFill>
-                  <a:srgbClr val="6B7280"/>
-                </a:solidFill>
-                <a:latin typeface="Arial"/>
-              </a:rPr>
-              <a:t> o </a:t>
-            </a:r>
-            <a:r>
-              <a:rPr sz="700" b="0" dirty="0" err="1">
-                <a:solidFill>
-                  <a:srgbClr val="6B7280"/>
-                </a:solidFill>
-                <a:latin typeface="Arial"/>
-              </a:rPr>
-              <a:t>scansione</a:t>
-            </a:r>
-            <a:r>
-              <a:rPr sz="700" b="0" dirty="0">
-                <a:solidFill>
-                  <a:srgbClr val="6B7280"/>
-                </a:solidFill>
-                <a:latin typeface="Arial"/>
-              </a:rPr>
-              <a:t> del </a:t>
-            </a:r>
-            <a:r>
-              <a:rPr sz="700" b="0" dirty="0" err="1">
-                <a:solidFill>
-                  <a:srgbClr val="6B7280"/>
-                </a:solidFill>
-                <a:latin typeface="Arial"/>
-              </a:rPr>
-              <a:t>cartaceo</a:t>
-            </a:r>
-            <a:r>
-              <a:rPr sz="700" b="0" dirty="0">
-                <a:solidFill>
-                  <a:srgbClr val="6B7280"/>
-                </a:solidFill>
-                <a:latin typeface="Arial"/>
-              </a:rPr>
-              <a:t> </a:t>
-            </a:r>
-            <a:r>
-              <a:rPr sz="700" b="0" dirty="0" err="1">
-                <a:solidFill>
-                  <a:srgbClr val="6B7280"/>
-                </a:solidFill>
-                <a:latin typeface="Arial"/>
-              </a:rPr>
-              <a:t>firmato</a:t>
-            </a:r>
-            <a:endParaRPr sz="700" b="0" dirty="0">
-              <a:solidFill>
-                <a:srgbClr val="6B7280"/>
-              </a:solidFill>
-              <a:latin typeface="Arial"/>
-            </a:endParaRPr>
+              <a:t>firma digitale o scansione del cartaceo firmato</a:t>
+            </a:r>
           </a:p>
         </p:txBody>
       </p:sp>
@@ -5589,13 +4647,13 @@
           <a:p>
             <a:pPr algn="ctr"/>
             <a:r>
-              <a:rPr sz="750" b="0">
+              <a:rPr lang="it-IT" sz="750" b="0" noProof="0" dirty="0">
                 <a:solidFill>
                   <a:srgbClr val="1F2937"/>
                 </a:solidFill>
                 <a:latin typeface="Arial"/>
               </a:rPr>
-              <a:t>R006 cartacea · R012 elettronica</a:t>
+              <a:t>R006 cartacea · R006 / R012 elettronica</a:t>
             </a:r>
           </a:p>
         </p:txBody>
@@ -5688,7 +4746,7 @@
           <a:p>
             <a:pPr algn="ctr"/>
             <a:r>
-              <a:rPr sz="900" b="1">
+              <a:rPr lang="it-IT" sz="900" b="1" noProof="0" dirty="0">
                 <a:solidFill>
                   <a:srgbClr val="1F2937"/>
                 </a:solidFill>
@@ -5700,7 +4758,7 @@
           <a:p>
             <a:pPr algn="ctr"/>
             <a:r>
-              <a:rPr sz="700" b="0">
+              <a:rPr lang="it-IT" sz="700" b="0" noProof="0" dirty="0">
                 <a:solidFill>
                   <a:srgbClr val="6B7280"/>
                 </a:solidFill>
@@ -5755,7 +4813,7 @@
           <a:p>
             <a:pPr algn="ctr"/>
             <a:r>
-              <a:rPr sz="750" b="0">
+              <a:rPr lang="it-IT" sz="750" b="0" noProof="0" dirty="0">
                 <a:solidFill>
                   <a:srgbClr val="1F2937"/>
                 </a:solidFill>
@@ -5853,73 +4911,31 @@
           <a:p>
             <a:pPr algn="ctr"/>
             <a:r>
-              <a:rPr sz="900" b="1" dirty="0" err="1">
+              <a:rPr lang="it-IT" sz="900" b="1" noProof="0" dirty="0">
                 <a:solidFill>
                   <a:srgbClr val="1F2937"/>
                 </a:solidFill>
                 <a:latin typeface="Arial"/>
               </a:rPr>
-              <a:t>Anteprima</a:t>
-            </a:r>
-            <a:r>
-              <a:rPr sz="900" b="1" dirty="0">
+              <a:t>Anteprima · firma dell’USC</a:t>
+            </a:r>
+            <a:br>
+              <a:rPr lang="it-IT" sz="900" b="1" noProof="0" dirty="0">
                 <a:solidFill>
                   <a:srgbClr val="1F2937"/>
                 </a:solidFill>
                 <a:latin typeface="Arial"/>
               </a:rPr>
-              <a:t> · </a:t>
-            </a:r>
-            <a:r>
-              <a:rPr sz="900" b="1" dirty="0" err="1">
+            </a:br>
+            <a:r>
+              <a:rPr lang="it-IT" sz="900" b="1" noProof="0" dirty="0">
                 <a:solidFill>
                   <a:srgbClr val="1F2937"/>
                 </a:solidFill>
                 <a:latin typeface="Arial"/>
               </a:rPr>
-              <a:t>firma</a:t>
-            </a:r>
-            <a:r>
-              <a:rPr sz="900" b="1" dirty="0">
-                <a:solidFill>
-                  <a:srgbClr val="1F2937"/>
-                </a:solidFill>
-                <a:latin typeface="Arial"/>
-              </a:rPr>
-              <a:t> </a:t>
-            </a:r>
-            <a:r>
-              <a:rPr sz="900" b="1" dirty="0" err="1">
-                <a:solidFill>
-                  <a:srgbClr val="1F2937"/>
-                </a:solidFill>
-                <a:latin typeface="Arial"/>
-              </a:rPr>
-              <a:t>dell’USC</a:t>
-            </a:r>
-            <a:br>
-              <a:rPr lang="it-IT" sz="900" b="1" dirty="0">
-                <a:solidFill>
-                  <a:srgbClr val="1F2937"/>
-                </a:solidFill>
-                <a:latin typeface="Arial"/>
-              </a:rPr>
-            </a:br>
-            <a:r>
-              <a:rPr lang="it-IT" sz="900" b="1" dirty="0">
-                <a:solidFill>
-                  <a:srgbClr val="1F2937"/>
-                </a:solidFill>
-                <a:latin typeface="Arial"/>
-              </a:rPr>
-              <a:t>Bottone «Definisci»</a:t>
-            </a:r>
-            <a:endParaRPr sz="900" b="1" dirty="0">
-              <a:solidFill>
-                <a:srgbClr val="1F2937"/>
-              </a:solidFill>
-              <a:latin typeface="Arial"/>
-            </a:endParaRPr>
+              <a:t>Bottone «Chiudi»</a:t>
+            </a:r>
           </a:p>
         </p:txBody>
       </p:sp>
@@ -5967,7 +4983,7 @@
           <a:p>
             <a:pPr algn="ctr"/>
             <a:r>
-              <a:rPr sz="750" b="0" dirty="0">
+              <a:rPr lang="it-IT" sz="750" b="0" noProof="0" dirty="0">
                 <a:solidFill>
                   <a:srgbClr val="1F2937"/>
                 </a:solidFill>
@@ -5976,7 +4992,7 @@
               <a:t>R007 /</a:t>
             </a:r>
             <a:r>
-              <a:rPr sz="750" b="0" dirty="0" err="1">
+              <a:rPr lang="it-IT" sz="750" b="0" noProof="0" dirty="0" err="1">
                 <a:solidFill>
                   <a:srgbClr val="1F2937"/>
                 </a:solidFill>
@@ -5984,7 +5000,7 @@
               </a:rPr>
               <a:t>firma_usc</a:t>
             </a:r>
-            <a:endParaRPr lang="it-IT" sz="750" b="0" dirty="0">
+            <a:endParaRPr lang="it-IT" sz="750" b="0" noProof="0" dirty="0">
               <a:solidFill>
                 <a:srgbClr val="1F2937"/>
               </a:solidFill>
@@ -5994,15 +5010,33 @@
           <a:p>
             <a:pPr algn="ctr"/>
             <a:r>
-              <a:rPr lang="it-IT" sz="750" dirty="0">
+              <a:rPr lang="it-IT" sz="750" noProof="0" dirty="0">
                 <a:solidFill>
                   <a:srgbClr val="1F2937"/>
                 </a:solidFill>
                 <a:latin typeface="Arial"/>
               </a:rPr>
+              <a:t>R014 Agg Anagrafe</a:t>
+            </a:r>
+            <a:endParaRPr lang="it-IT" sz="750" b="0" noProof="0" dirty="0">
+              <a:solidFill>
+                <a:srgbClr val="1F2937"/>
+              </a:solidFill>
+              <a:latin typeface="Arial"/>
+            </a:endParaRPr>
+          </a:p>
+          <a:p>
+            <a:pPr algn="ctr"/>
+            <a:r>
+              <a:rPr lang="it-IT" sz="750" noProof="0" dirty="0">
+                <a:solidFill>
+                  <a:srgbClr val="1F2937"/>
+                </a:solidFill>
+                <a:latin typeface="Arial"/>
+              </a:rPr>
               <a:t>Salva atto SIPO</a:t>
             </a:r>
-            <a:endParaRPr sz="750" b="0" dirty="0">
+            <a:endParaRPr lang="it-IT" sz="750" b="0" noProof="0" dirty="0">
               <a:solidFill>
                 <a:srgbClr val="1F2937"/>
               </a:solidFill>
@@ -6094,7 +5128,7 @@
           <a:p>
             <a:pPr algn="ctr"/>
             <a:r>
-              <a:rPr sz="750" b="0">
+              <a:rPr lang="it-IT" sz="750" b="0" noProof="0" dirty="0">
                 <a:solidFill>
                   <a:srgbClr val="1F2937"/>
                 </a:solidFill>
@@ -6190,7 +5224,7 @@
           <a:p>
             <a:pPr algn="ctr"/>
             <a:r>
-              <a:rPr sz="900" b="1" dirty="0" err="1">
+              <a:rPr lang="it-IT" sz="900" b="1" noProof="0" dirty="0">
                 <a:solidFill>
                   <a:srgbClr val="1F2937"/>
                 </a:solidFill>
@@ -6198,122 +5232,17 @@
               </a:rPr>
               <a:t>Chiudi</a:t>
             </a:r>
-            <a:endParaRPr sz="900" b="1" dirty="0">
-              <a:solidFill>
-                <a:srgbClr val="1F2937"/>
-              </a:solidFill>
-              <a:latin typeface="Arial"/>
-            </a:endParaRPr>
           </a:p>
           <a:p>
             <a:pPr algn="ctr"/>
             <a:r>
-              <a:rPr sz="700" b="0" dirty="0" err="1">
+              <a:rPr lang="it-IT" sz="700" b="0" noProof="0" dirty="0">
                 <a:solidFill>
                   <a:srgbClr val="6B7280"/>
                 </a:solidFill>
                 <a:latin typeface="Arial"/>
               </a:rPr>
-              <a:t>l’atto</a:t>
-            </a:r>
-            <a:r>
-              <a:rPr sz="700" b="0" dirty="0">
-                <a:solidFill>
-                  <a:srgbClr val="6B7280"/>
-                </a:solidFill>
-                <a:latin typeface="Arial"/>
-              </a:rPr>
-              <a:t> non </a:t>
-            </a:r>
-            <a:r>
-              <a:rPr sz="700" b="0" dirty="0" err="1">
-                <a:solidFill>
-                  <a:srgbClr val="6B7280"/>
-                </a:solidFill>
-                <a:latin typeface="Arial"/>
-              </a:rPr>
-              <a:t>si</a:t>
-            </a:r>
-            <a:r>
-              <a:rPr sz="700" b="0" dirty="0">
-                <a:solidFill>
-                  <a:srgbClr val="6B7280"/>
-                </a:solidFill>
-                <a:latin typeface="Arial"/>
-              </a:rPr>
-              <a:t> </a:t>
-            </a:r>
-            <a:r>
-              <a:rPr sz="700" b="0" dirty="0" err="1">
-                <a:solidFill>
-                  <a:srgbClr val="6B7280"/>
-                </a:solidFill>
-                <a:latin typeface="Arial"/>
-              </a:rPr>
-              <a:t>modifica</a:t>
-            </a:r>
-            <a:r>
-              <a:rPr sz="700" b="0" dirty="0">
-                <a:solidFill>
-                  <a:srgbClr val="6B7280"/>
-                </a:solidFill>
-                <a:latin typeface="Arial"/>
-              </a:rPr>
-              <a:t> </a:t>
-            </a:r>
-            <a:r>
-              <a:rPr sz="700" b="0" dirty="0" err="1">
-                <a:solidFill>
-                  <a:srgbClr val="6B7280"/>
-                </a:solidFill>
-                <a:latin typeface="Arial"/>
-              </a:rPr>
-              <a:t>più</a:t>
-            </a:r>
-            <a:r>
-              <a:rPr sz="700" b="0" dirty="0">
-                <a:solidFill>
-                  <a:srgbClr val="6B7280"/>
-                </a:solidFill>
-                <a:latin typeface="Arial"/>
-              </a:rPr>
-              <a:t>, </a:t>
-            </a:r>
-            <a:r>
-              <a:rPr sz="700" b="0" dirty="0" err="1">
-                <a:solidFill>
-                  <a:srgbClr val="6B7280"/>
-                </a:solidFill>
-                <a:latin typeface="Arial"/>
-              </a:rPr>
-              <a:t>nemmeno</a:t>
-            </a:r>
-            <a:r>
-              <a:rPr sz="700" b="0" dirty="0">
-                <a:solidFill>
-                  <a:srgbClr val="6B7280"/>
-                </a:solidFill>
-                <a:latin typeface="Arial"/>
-              </a:rPr>
-              <a:t> </a:t>
-            </a:r>
-            <a:r>
-              <a:rPr sz="700" b="0" dirty="0" err="1">
-                <a:solidFill>
-                  <a:srgbClr val="6B7280"/>
-                </a:solidFill>
-                <a:latin typeface="Arial"/>
-              </a:rPr>
-              <a:t>fino</a:t>
-            </a:r>
-            <a:r>
-              <a:rPr sz="700" b="0" dirty="0">
-                <a:solidFill>
-                  <a:srgbClr val="6B7280"/>
-                </a:solidFill>
-                <a:latin typeface="Arial"/>
-              </a:rPr>
-              <a:t> alle 24</a:t>
+              <a:t>l’atto non si modifica più, nemmeno fino alle 24</a:t>
             </a:r>
           </a:p>
         </p:txBody>
@@ -6719,7 +5648,7 @@
         <p:spPr>
           <a:xfrm>
             <a:off x="4151376" y="1188720"/>
-            <a:ext cx="1325880" cy="2962656"/>
+            <a:ext cx="646937" cy="2962656"/>
           </a:xfrm>
           <a:prstGeom prst="roundRect">
             <a:avLst>
@@ -6757,19 +5686,19 @@
           <a:p>
             <a:pPr algn="ctr"/>
             <a:r>
-              <a:rPr sz="900" b="1">
+              <a:rPr lang="it-IT" sz="900" b="1" noProof="0" dirty="0">
                 <a:solidFill>
                   <a:srgbClr val="1F2937"/>
                 </a:solidFill>
                 <a:latin typeface="Arial"/>
               </a:rPr>
-              <a:t>Nessun atto in ANSC</a:t>
+              <a:t>Iniziale nessun atto in ANSC</a:t>
             </a:r>
           </a:p>
           <a:p>
             <a:pPr algn="ctr"/>
             <a:r>
-              <a:rPr sz="700" b="0">
+              <a:rPr lang="it-IT" sz="700" b="0" noProof="0" dirty="0">
                 <a:solidFill>
                   <a:srgbClr val="6B7280"/>
                 </a:solidFill>
@@ -6826,7 +5755,7 @@
           <a:p>
             <a:pPr algn="ctr"/>
             <a:r>
-              <a:rPr sz="850" b="1">
+              <a:rPr lang="it-IT" sz="850" b="1" noProof="0" dirty="0">
                 <a:solidFill>
                   <a:srgbClr val="1F2937"/>
                 </a:solidFill>
@@ -6883,7 +5812,7 @@
           <a:p>
             <a:pPr algn="ctr"/>
             <a:r>
-              <a:rPr sz="850" b="1">
+              <a:rPr lang="it-IT" sz="850" b="1" noProof="0" dirty="0">
                 <a:solidFill>
                   <a:srgbClr val="1F2937"/>
                 </a:solidFill>
@@ -6940,7 +5869,7 @@
           <a:p>
             <a:pPr algn="ctr"/>
             <a:r>
-              <a:rPr sz="850" b="1">
+              <a:rPr lang="it-IT" sz="850" b="1" noProof="0" dirty="0">
                 <a:solidFill>
                   <a:srgbClr val="1F2937"/>
                 </a:solidFill>
@@ -6997,7 +5926,7 @@
           <a:p>
             <a:pPr algn="ctr"/>
             <a:r>
-              <a:rPr sz="850" b="1">
+              <a:rPr lang="it-IT" sz="850" b="1" noProof="0" dirty="0">
                 <a:solidFill>
                   <a:srgbClr val="1F2937"/>
                 </a:solidFill>
@@ -7012,15 +5941,16 @@
         <p:nvCxnSpPr>
           <p:cNvPr id="56" name="Connector 55"/>
           <p:cNvCxnSpPr>
+            <a:cxnSpLocks/>
             <a:stCxn id="51" idx="2"/>
             <a:endCxn id="52" idx="0"/>
           </p:cNvCxnSpPr>
           <p:nvPr/>
         </p:nvCxnSpPr>
         <p:spPr>
-          <a:xfrm flipH="1">
-            <a:off x="4814316" y="4151376"/>
-            <a:ext cx="0" cy="100584"/>
+          <a:xfrm>
+            <a:off x="4474845" y="4151376"/>
+            <a:ext cx="339471" cy="100584"/>
           </a:xfrm>
           <a:prstGeom prst="line">
             <a:avLst/>
@@ -7188,7 +6118,7 @@
           <a:p>
             <a:pPr algn="l"/>
             <a:r>
-              <a:rPr sz="600" b="0" i="0">
+              <a:rPr lang="it-IT" sz="600" b="0" i="0" noProof="0" dirty="0">
                 <a:solidFill>
                   <a:srgbClr val="6B7280"/>
                 </a:solidFill>
@@ -7262,7 +6192,7 @@
           <a:lstStyle/>
           <a:p>
             <a:pPr algn="ctr"/>
-            <a:endParaRPr/>
+            <a:endParaRPr lang="it-IT" noProof="0" dirty="0"/>
           </a:p>
         </p:txBody>
       </p:sp>
@@ -7290,7 +6220,7 @@
           <a:p>
             <a:pPr algn="ctr"/>
             <a:r>
-              <a:rPr sz="600" b="0" i="0">
+              <a:rPr lang="it-IT" sz="600" b="0" i="0" noProof="0" dirty="0">
                 <a:solidFill>
                   <a:srgbClr val="6B7280"/>
                 </a:solidFill>
@@ -7364,7 +6294,7 @@
           <a:lstStyle/>
           <a:p>
             <a:pPr algn="ctr"/>
-            <a:endParaRPr/>
+            <a:endParaRPr lang="it-IT" noProof="0" dirty="0"/>
           </a:p>
         </p:txBody>
       </p:sp>
@@ -7392,7 +6322,7 @@
           <a:p>
             <a:pPr algn="ctr"/>
             <a:r>
-              <a:rPr sz="600" b="0" i="0">
+              <a:rPr lang="it-IT" sz="600" b="0" i="0" noProof="0" dirty="0">
                 <a:solidFill>
                   <a:srgbClr val="B03A48"/>
                 </a:solidFill>
@@ -7450,7 +6380,7 @@
           <a:p>
             <a:pPr algn="ctr"/>
             <a:r>
-              <a:rPr sz="850" b="1">
+              <a:rPr lang="it-IT" sz="850" b="1" noProof="0" dirty="0">
                 <a:solidFill>
                   <a:srgbClr val="6B7280"/>
                 </a:solidFill>
@@ -7507,7 +6437,7 @@
           <a:p>
             <a:pPr algn="ctr"/>
             <a:r>
-              <a:rPr sz="1100" b="1" dirty="0">
+              <a:rPr lang="it-IT" sz="1100" b="1" noProof="0" dirty="0">
                 <a:solidFill>
                   <a:srgbClr val="1F2937"/>
                 </a:solidFill>
@@ -7519,7 +6449,7 @@
           <a:p>
             <a:pPr algn="ctr"/>
             <a:r>
-              <a:rPr sz="800" b="1" dirty="0">
+              <a:rPr lang="it-IT" sz="800" b="1" noProof="0" dirty="0">
                 <a:solidFill>
                   <a:srgbClr val="1F2937"/>
                 </a:solidFill>
@@ -7531,56 +6461,14 @@
           <a:p>
             <a:pPr algn="ctr"/>
             <a:r>
-              <a:rPr sz="650" b="0" dirty="0" err="1">
+              <a:rPr lang="it-IT" sz="650" b="0" noProof="0" dirty="0">
                 <a:solidFill>
                   <a:srgbClr val="6B7280"/>
                 </a:solidFill>
                 <a:latin typeface="Arial"/>
               </a:rPr>
-              <a:t>nasce</a:t>
-            </a:r>
-            <a:r>
-              <a:rPr sz="650" b="0" dirty="0">
-                <a:solidFill>
-                  <a:srgbClr val="6B7280"/>
-                </a:solidFill>
-                <a:latin typeface="Arial"/>
-              </a:rPr>
-              <a:t> col </a:t>
-            </a:r>
-            <a:r>
-              <a:rPr sz="650" b="0" dirty="0" err="1">
-                <a:solidFill>
-                  <a:srgbClr val="6B7280"/>
-                </a:solidFill>
-                <a:latin typeface="Arial"/>
-              </a:rPr>
-              <a:t>numero</a:t>
-            </a:r>
-            <a:r>
-              <a:rPr sz="650" b="0" dirty="0">
-                <a:solidFill>
-                  <a:srgbClr val="6B7280"/>
-                </a:solidFill>
-                <a:latin typeface="Arial"/>
-              </a:rPr>
-              <a:t> </a:t>
-            </a:r>
-            <a:r>
-              <a:rPr sz="650" b="0" dirty="0" err="1">
-                <a:solidFill>
-                  <a:srgbClr val="6B7280"/>
-                </a:solidFill>
-                <a:latin typeface="Arial"/>
-              </a:rPr>
-              <a:t>provvisorio</a:t>
-            </a:r>
-            <a:endParaRPr sz="650" b="0" dirty="0">
-              <a:solidFill>
-                <a:srgbClr val="6B7280"/>
-              </a:solidFill>
-              <a:latin typeface="Arial"/>
-            </a:endParaRPr>
+              <a:t>nasce col numero provvisorio</a:t>
+            </a:r>
           </a:p>
         </p:txBody>
       </p:sp>
@@ -7630,7 +6518,7 @@
           <a:p>
             <a:pPr algn="ctr"/>
             <a:r>
-              <a:rPr sz="1100" b="1">
+              <a:rPr lang="it-IT" sz="1100" b="1" noProof="0" dirty="0">
                 <a:solidFill>
                   <a:srgbClr val="1F2937"/>
                 </a:solidFill>
@@ -7642,7 +6530,7 @@
           <a:p>
             <a:pPr algn="ctr"/>
             <a:r>
-              <a:rPr sz="800" b="1">
+              <a:rPr lang="it-IT" sz="800" b="1" noProof="0" dirty="0">
                 <a:solidFill>
                   <a:srgbClr val="1F2937"/>
                 </a:solidFill>
@@ -7755,7 +6643,7 @@
           <a:p>
             <a:pPr algn="l"/>
             <a:r>
-              <a:rPr sz="600" b="0" i="0">
+              <a:rPr lang="it-IT" sz="600" b="0" i="0" noProof="0" dirty="0">
                 <a:solidFill>
                   <a:srgbClr val="6B7280"/>
                 </a:solidFill>
@@ -7826,7 +6714,7 @@
           <a:p>
             <a:pPr algn="l"/>
             <a:r>
-              <a:rPr sz="650" b="1" i="0">
+              <a:rPr lang="it-IT" sz="650" b="1" i="0" noProof="0" dirty="0">
                 <a:solidFill>
                   <a:srgbClr val="B03A48"/>
                 </a:solidFill>
@@ -7883,7 +6771,7 @@
           <a:p>
             <a:pPr algn="ctr"/>
             <a:r>
-              <a:rPr sz="850" b="1">
+              <a:rPr lang="it-IT" sz="850" b="1" noProof="0" dirty="0">
                 <a:solidFill>
                   <a:srgbClr val="1F2937"/>
                 </a:solidFill>
@@ -7895,7 +6783,7 @@
           <a:p>
             <a:pPr algn="ctr"/>
             <a:r>
-              <a:rPr sz="750" b="0">
+              <a:rPr lang="it-IT" sz="750" b="0" noProof="0" dirty="0">
                 <a:solidFill>
                   <a:srgbClr val="1F2937"/>
                 </a:solidFill>
@@ -7907,7 +6795,7 @@
           <a:p>
             <a:pPr algn="ctr"/>
             <a:r>
-              <a:rPr sz="750" b="0">
+              <a:rPr lang="it-IT" sz="750" b="0" noProof="0" dirty="0">
                 <a:solidFill>
                   <a:srgbClr val="1F2937"/>
                 </a:solidFill>
@@ -8001,7 +6889,7 @@
           <a:lstStyle/>
           <a:p>
             <a:pPr algn="ctr"/>
-            <a:endParaRPr/>
+            <a:endParaRPr lang="it-IT" noProof="0" dirty="0"/>
           </a:p>
         </p:txBody>
       </p:sp>
@@ -8029,22 +6917,13 @@
           <a:p>
             <a:pPr algn="l"/>
             <a:r>
-              <a:rPr sz="700" b="0" i="0" dirty="0" err="1">
+              <a:rPr lang="it-IT" sz="700" b="0" i="0" noProof="0" dirty="0">
                 <a:solidFill>
                   <a:srgbClr val="6B7280"/>
                 </a:solidFill>
                 <a:latin typeface="Arial"/>
               </a:rPr>
-              <a:t>pagina</a:t>
-            </a:r>
-            <a:r>
-              <a:rPr sz="700" b="0" i="0" dirty="0">
-                <a:solidFill>
-                  <a:srgbClr val="6B7280"/>
-                </a:solidFill>
-                <a:latin typeface="Arial"/>
-              </a:rPr>
-              <a:t> di SIPO</a:t>
+              <a:t>pagina di SIPO</a:t>
             </a:r>
           </a:p>
         </p:txBody>
@@ -8092,7 +6971,7 @@
           <a:lstStyle/>
           <a:p>
             <a:pPr algn="ctr"/>
-            <a:endParaRPr/>
+            <a:endParaRPr lang="it-IT" noProof="0" dirty="0"/>
           </a:p>
         </p:txBody>
       </p:sp>
@@ -8120,7 +6999,7 @@
           <a:p>
             <a:pPr algn="l"/>
             <a:r>
-              <a:rPr sz="700" b="0" i="0">
+              <a:rPr lang="it-IT" sz="700" b="0" i="0" noProof="0" dirty="0">
                 <a:solidFill>
                   <a:srgbClr val="6B7280"/>
                 </a:solidFill>
@@ -8174,7 +7053,7 @@
           <a:lstStyle/>
           <a:p>
             <a:pPr algn="ctr"/>
-            <a:endParaRPr/>
+            <a:endParaRPr lang="it-IT" noProof="0" dirty="0"/>
           </a:p>
         </p:txBody>
       </p:sp>
@@ -8202,7 +7081,7 @@
           <a:p>
             <a:pPr algn="l"/>
             <a:r>
-              <a:rPr sz="700" b="0" i="0">
+              <a:rPr lang="it-IT" sz="700" b="0" i="0" noProof="0" dirty="0">
                 <a:solidFill>
                   <a:srgbClr val="6B7280"/>
                 </a:solidFill>
@@ -8256,7 +7135,7 @@
           <a:lstStyle/>
           <a:p>
             <a:pPr algn="ctr"/>
-            <a:endParaRPr/>
+            <a:endParaRPr lang="it-IT" noProof="0" dirty="0"/>
           </a:p>
         </p:txBody>
       </p:sp>
@@ -8284,7 +7163,7 @@
           <a:p>
             <a:pPr algn="l"/>
             <a:r>
-              <a:rPr sz="700" b="0" i="0">
+              <a:rPr lang="it-IT" sz="700" b="0" i="0" noProof="0" dirty="0">
                 <a:solidFill>
                   <a:srgbClr val="6B7280"/>
                 </a:solidFill>
@@ -8338,7 +7217,7 @@
           <a:lstStyle/>
           <a:p>
             <a:pPr algn="ctr"/>
-            <a:endParaRPr/>
+            <a:endParaRPr lang="it-IT" noProof="0" dirty="0"/>
           </a:p>
         </p:txBody>
       </p:sp>
@@ -8366,7 +7245,7 @@
           <a:p>
             <a:pPr algn="l"/>
             <a:r>
-              <a:rPr sz="700" b="0" i="0">
+              <a:rPr lang="it-IT" sz="700" b="0" i="0" noProof="0" dirty="0">
                 <a:solidFill>
                   <a:srgbClr val="6B7280"/>
                 </a:solidFill>
@@ -8401,7 +7280,7 @@
           <a:p>
             <a:pPr algn="l"/>
             <a:r>
-              <a:rPr sz="650" b="0" i="1">
+              <a:rPr lang="it-IT" sz="650" b="0" i="1" noProof="0" dirty="0">
                 <a:solidFill>
                   <a:srgbClr val="6B7280"/>
                 </a:solidFill>
@@ -8457,7 +7336,7 @@
           <a:lstStyle/>
           <a:p>
             <a:pPr algn="ctr"/>
-            <a:endParaRPr lang="it-IT"/>
+            <a:endParaRPr lang="it-IT" noProof="0" dirty="0"/>
           </a:p>
         </p:txBody>
       </p:sp>
@@ -8506,7 +7385,7 @@
           <a:lstStyle/>
           <a:p>
             <a:pPr algn="ctr"/>
-            <a:endParaRPr lang="it-IT"/>
+            <a:endParaRPr lang="it-IT" noProof="0" dirty="0"/>
           </a:p>
         </p:txBody>
       </p:sp>
@@ -8555,7 +7434,7 @@
           <a:lstStyle/>
           <a:p>
             <a:pPr algn="ctr"/>
-            <a:endParaRPr lang="it-IT"/>
+            <a:endParaRPr lang="it-IT" noProof="0" dirty="0"/>
           </a:p>
         </p:txBody>
       </p:sp>
@@ -8604,7 +7483,7 @@
           <a:lstStyle/>
           <a:p>
             <a:pPr algn="ctr"/>
-            <a:endParaRPr lang="it-IT"/>
+            <a:endParaRPr lang="it-IT" noProof="0" dirty="0"/>
           </a:p>
         </p:txBody>
       </p:sp>
@@ -8653,7 +7532,7 @@
           <a:lstStyle/>
           <a:p>
             <a:pPr algn="ctr"/>
-            <a:endParaRPr lang="it-IT"/>
+            <a:endParaRPr lang="it-IT" noProof="0" dirty="0"/>
           </a:p>
         </p:txBody>
       </p:sp>
@@ -8702,7 +7581,7 @@
           <a:lstStyle/>
           <a:p>
             <a:pPr algn="ctr"/>
-            <a:endParaRPr lang="it-IT"/>
+            <a:endParaRPr lang="it-IT" noProof="0" dirty="0"/>
           </a:p>
         </p:txBody>
       </p:sp>
@@ -8751,7 +7630,7 @@
           <a:lstStyle/>
           <a:p>
             <a:pPr algn="ctr"/>
-            <a:endParaRPr lang="it-IT"/>
+            <a:endParaRPr lang="it-IT" noProof="0" dirty="0"/>
           </a:p>
         </p:txBody>
       </p:sp>
@@ -8785,7 +7664,7 @@
           <a:p>
             <a:pPr algn="l"/>
             <a:r>
-              <a:rPr lang="it-IT" sz="700" b="0" i="0" dirty="0">
+              <a:rPr lang="it-IT" sz="700" b="0" i="0" noProof="0" dirty="0">
                 <a:solidFill>
                   <a:srgbClr val="6B7280"/>
                 </a:solidFill>
@@ -8793,7 +7672,112 @@
               </a:rPr>
               <a:t>Necessario OTP ANSC</a:t>
             </a:r>
-            <a:endParaRPr sz="700" b="0" i="0" dirty="0">
+          </a:p>
+        </p:txBody>
+      </p:sp>
+      <p:sp>
+        <p:nvSpPr>
+          <p:cNvPr id="86" name="Rounded Rectangle 50">
+            <a:extLst>
+              <a:ext uri="{FF2B5EF4-FFF2-40B4-BE49-F238E27FC236}">
+                <a16:creationId xmlns:a16="http://schemas.microsoft.com/office/drawing/2014/main" id="{56B3C57A-7345-B880-A5D3-A5848323D518}"/>
+              </a:ext>
+            </a:extLst>
+          </p:cNvPr>
+          <p:cNvSpPr/>
+          <p:nvPr/>
+        </p:nvSpPr>
+        <p:spPr>
+          <a:xfrm>
+            <a:off x="4892041" y="1801368"/>
+            <a:ext cx="571500" cy="2342576"/>
+          </a:xfrm>
+          <a:prstGeom prst="roundRect">
+            <a:avLst>
+              <a:gd name="adj" fmla="val 12000"/>
+            </a:avLst>
+          </a:prstGeom>
+          <a:solidFill>
+            <a:srgbClr val="E9EAEC"/>
+          </a:solidFill>
+          <a:ln w="13970">
+            <a:solidFill>
+              <a:srgbClr val="6B7280"/>
+            </a:solidFill>
+            <a:prstDash val="dash"/>
+          </a:ln>
+          <a:effectLst/>
+        </p:spPr>
+        <p:style>
+          <a:lnRef idx="1">
+            <a:schemeClr val="accent1"/>
+          </a:lnRef>
+          <a:fillRef idx="3">
+            <a:schemeClr val="accent1"/>
+          </a:fillRef>
+          <a:effectRef idx="2">
+            <a:schemeClr val="accent1"/>
+          </a:effectRef>
+          <a:fontRef idx="minor">
+            <a:schemeClr val="lt1"/>
+          </a:fontRef>
+        </p:style>
+        <p:txBody>
+          <a:bodyPr wrap="square" lIns="45720" tIns="18288" rIns="45720" bIns="18288" rtlCol="0" anchor="ctr"/>
+          <a:lstStyle/>
+          <a:p>
+            <a:pPr algn="ctr"/>
+            <a:r>
+              <a:rPr lang="it-IT" sz="900" b="1" noProof="0" dirty="0">
+                <a:solidFill>
+                  <a:srgbClr val="1F2937"/>
+                </a:solidFill>
+                <a:latin typeface="Arial"/>
+              </a:rPr>
+              <a:t>Post validazione ANSC</a:t>
+            </a:r>
+          </a:p>
+          <a:p>
+            <a:pPr algn="ctr"/>
+            <a:r>
+              <a:rPr lang="it-IT" sz="700" b="0" noProof="0" dirty="0">
+                <a:solidFill>
+                  <a:srgbClr val="6B7280"/>
+                </a:solidFill>
+                <a:latin typeface="Arial"/>
+              </a:rPr>
+              <a:t>UC noto</a:t>
+            </a:r>
+          </a:p>
+          <a:p>
+            <a:pPr algn="ctr"/>
+            <a:r>
+              <a:rPr lang="it-IT" sz="700" noProof="0" dirty="0">
+                <a:solidFill>
+                  <a:srgbClr val="6B7280"/>
+                </a:solidFill>
+                <a:latin typeface="Arial"/>
+              </a:rPr>
+              <a:t>IdAnsc acquisito</a:t>
+            </a:r>
+            <a:br>
+              <a:rPr lang="it-IT" sz="700" noProof="0" dirty="0">
+                <a:solidFill>
+                  <a:srgbClr val="6B7280"/>
+                </a:solidFill>
+                <a:latin typeface="Arial"/>
+              </a:rPr>
+            </a:br>
+            <a:r>
+              <a:rPr lang="it-IT" sz="700" noProof="0" dirty="0">
+                <a:solidFill>
+                  <a:srgbClr val="6B7280"/>
+                </a:solidFill>
+                <a:latin typeface="Arial"/>
+              </a:rPr>
+              <a:t>STATO_ANSC = 0 /BOZZA</a:t>
+            </a:r>
+            <a:endParaRPr lang="it-IT" sz="700" b="0" noProof="0" dirty="0">
               <a:solidFill>
                 <a:srgbClr val="6B7280"/>
               </a:solidFill>

</xml_diff>